<commit_message>
refactor: update itinerary copy and add icons
Refine expedition narrative for better flow and tone consistency, and update icon dependencies for future feature support.
</commit_message>
<xml_diff>
--- a/public/Explora_Cordillera_Blanca_Expedition.pptx
+++ b/public/Explora_Cordillera_Blanca_Expedition.pptx
@@ -4032,7 +4032,7 @@
                 <a:ea typeface="Arial" pitchFamily="34" charset="-122"/>
                 <a:cs typeface="Arial" pitchFamily="34" charset="-120"/>
               </a:rPr>
-              <a:t>A colossal overland journey climbing between the eastern walls of Mount Huascarán and Chopicalqui to cross Punta Olímpica Tunnel (15,530 ft), the highest vehicular tunnel in the world.</a:t>
+              <a:t>A scenic overland crossing of the continental divide, tracing the rugged pass between Mount Huascarán and Chopicalqui before piercing Punta Olímpica at 15,530 feet. As the route reveals Huascarán from dramatic, ever-shifting angles, the high alpine gives way to the verdant eastern valleys of Chacas, a tranquil colonial enclave famed for its carved timber balconies.</a:t>
             </a:r>
             <a:endParaRPr lang="en-US" sz="1150" dirty="0"/>
           </a:p>
@@ -4061,7 +4061,7 @@
                 <a:ea typeface="Arial" pitchFamily="34" charset="-122"/>
                 <a:cs typeface="Arial" pitchFamily="34" charset="-120"/>
               </a:rPr>
-              <a:t>We descend into the lush eastern valleys toward Chacas, a colonial town frozen in time with hand-carved balconies and cobblestones. Here we encounter the moving legacy of Father Ugo de Censi and the Don Bosco Artisans: local Quechua youths trained in Renaissance Italian wood carving, stone sculpture, and stained glass whose works grace the Vatican.</a:t>
+              <a:t>Here, travelers encounter one of the Andes’ most profound social legacies: the Don Bosco ateliers founded by Father Ugo de Censi, where Quechua craftspeople master Renaissance joinery, stone sculpture, and stained glass commissioned by cathedrals worldwide and the Vatican.</a:t>
             </a:r>
             <a:endParaRPr lang="en-US" sz="1150" dirty="0"/>
           </a:p>
@@ -4090,7 +4090,7 @@
                 <a:ea typeface="Arial" pitchFamily="34" charset="-122"/>
                 <a:cs typeface="Arial" pitchFamily="34" charset="-120"/>
               </a:rPr>
-              <a:t>We complete the day at Cuesta Serena Lodge with a celebratory dinner facing Mount Huascarán.</a:t>
+              <a:t>The day draws to a close at Cuesta Serena Lodge, with evening views across the Cordillera Blanca.</a:t>
             </a:r>
             <a:endParaRPr lang="en-US" sz="1150" dirty="0"/>
           </a:p>
@@ -5901,7 +5901,7 @@
                 <a:ea typeface="Arial" pitchFamily="34" charset="-122"/>
                 <a:cs typeface="Arial" pitchFamily="34" charset="-120"/>
               </a:rPr>
-              <a:t>CURATED MOUNTAIN OUTPOSTS</a:t>
+              <a:t>CURATED MOUNTAIN LODGES</a:t>
             </a:r>
             <a:endParaRPr lang="en-US" sz="1000" dirty="0"/>
           </a:p>
@@ -5948,14 +5948,53 @@
       </p:sp>
       <p:sp>
         <p:nvSpPr>
-          <p:cNvPr id="4" name="Shape 2"/>
-          <p:cNvSpPr/>
-          <p:nvPr/>
-        </p:nvSpPr>
-        <p:spPr>
-          <a:xfrm>
-            <a:off x="731520" y="1645920"/>
-            <a:ext cx="3429000" cy="4389120"/>
+          <p:cNvPr id="4" name="Text 2"/>
+          <p:cNvSpPr/>
+          <p:nvPr/>
+        </p:nvSpPr>
+        <p:spPr>
+          <a:xfrm>
+            <a:off x="731520" y="1051560"/>
+            <a:ext cx="10515600" cy="411480"/>
+          </a:xfrm>
+          <a:prstGeom prst="rect">
+            <a:avLst/>
+          </a:prstGeom>
+          <a:noFill/>
+          <a:ln/>
+        </p:spPr>
+        <p:txBody>
+          <a:bodyPr wrap="square" rtlCol="0" anchor="ctr"/>
+          <a:lstStyle/>
+          <a:p>
+            <a:pPr indent="0" marL="0">
+              <a:buNone/>
+            </a:pPr>
+            <a:r>
+              <a:rPr lang="en-US" sz="1150" dirty="0">
+                <a:solidFill>
+                  <a:srgbClr val="555555"/>
+                </a:solidFill>
+                <a:latin typeface="Arial" pitchFamily="34" charset="0"/>
+                <a:ea typeface="Arial" pitchFamily="34" charset="-122"/>
+                <a:cs typeface="Arial" pitchFamily="34" charset="-120"/>
+              </a:rPr>
+              <a:t>Explora’s lodging philosophy embraces "the luxury of the essential": intimate, character-filled mountain properties serving as strategic sanctuaries for restorative sleep, altitude oxygenation, and territorial immersion.</a:t>
+            </a:r>
+            <a:endParaRPr lang="en-US" sz="1150" dirty="0"/>
+          </a:p>
+        </p:txBody>
+      </p:sp>
+      <p:sp>
+        <p:nvSpPr>
+          <p:cNvPr id="5" name="Shape 3"/>
+          <p:cNvSpPr/>
+          <p:nvPr/>
+        </p:nvSpPr>
+        <p:spPr>
+          <a:xfrm>
+            <a:off x="731520" y="1508760"/>
+            <a:ext cx="3429000" cy="4023360"/>
           </a:xfrm>
           <a:prstGeom prst="rect">
             <a:avLst/>
@@ -5973,30 +6012,69 @@
       </p:sp>
       <p:sp>
         <p:nvSpPr>
-          <p:cNvPr id="5" name="Text 3"/>
-          <p:cNvSpPr/>
-          <p:nvPr/>
-        </p:nvSpPr>
-        <p:spPr>
-          <a:xfrm>
-            <a:off x="1005840" y="2011680"/>
-            <a:ext cx="2880360" cy="457200"/>
-          </a:xfrm>
-          <a:prstGeom prst="rect">
-            <a:avLst/>
-          </a:prstGeom>
-          <a:noFill/>
-          <a:ln/>
-        </p:spPr>
-        <p:txBody>
-          <a:bodyPr wrap="square" rtlCol="0" anchor="ctr"/>
-          <a:lstStyle/>
-          <a:p>
-            <a:pPr indent="0" marL="0">
-              <a:buNone/>
-            </a:pPr>
-            <a:r>
-              <a:rPr lang="en-US" sz="1600" b="1" dirty="0">
+          <p:cNvPr id="6" name="Text 4"/>
+          <p:cNvSpPr/>
+          <p:nvPr/>
+        </p:nvSpPr>
+        <p:spPr>
+          <a:xfrm>
+            <a:off x="1005840" y="1691640"/>
+            <a:ext cx="2880360" cy="228600"/>
+          </a:xfrm>
+          <a:prstGeom prst="rect">
+            <a:avLst/>
+          </a:prstGeom>
+          <a:noFill/>
+          <a:ln/>
+        </p:spPr>
+        <p:txBody>
+          <a:bodyPr wrap="square" rtlCol="0" anchor="ctr"/>
+          <a:lstStyle/>
+          <a:p>
+            <a:pPr indent="0" marL="0">
+              <a:buNone/>
+            </a:pPr>
+            <a:r>
+              <a:rPr lang="en-US" sz="900" b="1" spc="200" kern="0" dirty="0">
+                <a:solidFill>
+                  <a:srgbClr val="C69255"/>
+                </a:solidFill>
+                <a:latin typeface="Arial" pitchFamily="34" charset="0"/>
+                <a:ea typeface="Arial" pitchFamily="34" charset="-122"/>
+                <a:cs typeface="Arial" pitchFamily="34" charset="-120"/>
+              </a:rPr>
+              <a:t>NIGHTS 1 &amp; 2</a:t>
+            </a:r>
+            <a:endParaRPr lang="en-US" sz="900" dirty="0"/>
+          </a:p>
+        </p:txBody>
+      </p:sp>
+      <p:sp>
+        <p:nvSpPr>
+          <p:cNvPr id="7" name="Text 5"/>
+          <p:cNvSpPr/>
+          <p:nvPr/>
+        </p:nvSpPr>
+        <p:spPr>
+          <a:xfrm>
+            <a:off x="1005840" y="1965960"/>
+            <a:ext cx="2880360" cy="411480"/>
+          </a:xfrm>
+          <a:prstGeom prst="rect">
+            <a:avLst/>
+          </a:prstGeom>
+          <a:noFill/>
+          <a:ln/>
+        </p:spPr>
+        <p:txBody>
+          <a:bodyPr wrap="square" rtlCol="0" anchor="ctr"/>
+          <a:lstStyle/>
+          <a:p>
+            <a:pPr indent="0" marL="0">
+              <a:buNone/>
+            </a:pPr>
+            <a:r>
+              <a:rPr lang="en-US" sz="1500" b="1" dirty="0">
                 <a:solidFill>
                   <a:srgbClr val="111111"/>
                 </a:solidFill>
@@ -6006,38 +6084,38 @@
               </a:rPr>
               <a:t>Santa Cruz Lodge</a:t>
             </a:r>
-            <a:endParaRPr lang="en-US" sz="1600" dirty="0"/>
-          </a:p>
-        </p:txBody>
-      </p:sp>
-      <p:sp>
-        <p:nvSpPr>
-          <p:cNvPr id="6" name="Text 4"/>
-          <p:cNvSpPr/>
-          <p:nvPr/>
-        </p:nvSpPr>
-        <p:spPr>
-          <a:xfrm>
-            <a:off x="1005840" y="2468880"/>
-            <a:ext cx="2880360" cy="274320"/>
-          </a:xfrm>
-          <a:prstGeom prst="rect">
-            <a:avLst/>
-          </a:prstGeom>
-          <a:noFill/>
-          <a:ln/>
-        </p:spPr>
-        <p:txBody>
-          <a:bodyPr wrap="square" rtlCol="0" anchor="ctr"/>
-          <a:lstStyle/>
-          <a:p>
-            <a:pPr indent="0" marL="0">
-              <a:buNone/>
-            </a:pPr>
-            <a:r>
-              <a:rPr lang="en-US" sz="1000" b="1" dirty="0">
-                <a:solidFill>
-                  <a:srgbClr val="C69255"/>
+            <a:endParaRPr lang="en-US" sz="1500" dirty="0"/>
+          </a:p>
+        </p:txBody>
+      </p:sp>
+      <p:sp>
+        <p:nvSpPr>
+          <p:cNvPr id="8" name="Text 6"/>
+          <p:cNvSpPr/>
+          <p:nvPr/>
+        </p:nvSpPr>
+        <p:spPr>
+          <a:xfrm>
+            <a:off x="1005840" y="2423160"/>
+            <a:ext cx="2880360" cy="228600"/>
+          </a:xfrm>
+          <a:prstGeom prst="rect">
+            <a:avLst/>
+          </a:prstGeom>
+          <a:noFill/>
+          <a:ln/>
+        </p:spPr>
+        <p:txBody>
+          <a:bodyPr wrap="square" rtlCol="0" anchor="ctr"/>
+          <a:lstStyle/>
+          <a:p>
+            <a:pPr indent="0" marL="0">
+              <a:buNone/>
+            </a:pPr>
+            <a:r>
+              <a:rPr lang="en-US" sz="950" b="1" dirty="0">
+                <a:solidFill>
+                  <a:srgbClr val="666666"/>
                 </a:solidFill>
                 <a:latin typeface="Arial" pitchFamily="34" charset="0"/>
                 <a:ea typeface="Arial" pitchFamily="34" charset="-122"/>
@@ -6045,20 +6123,59 @@
               </a:rPr>
               <a:t>Caraz • 7,380 ft / 2,250 m</a:t>
             </a:r>
+            <a:endParaRPr lang="en-US" sz="950" dirty="0"/>
+          </a:p>
+        </p:txBody>
+      </p:sp>
+      <p:sp>
+        <p:nvSpPr>
+          <p:cNvPr id="9" name="Text 7"/>
+          <p:cNvSpPr/>
+          <p:nvPr/>
+        </p:nvSpPr>
+        <p:spPr>
+          <a:xfrm>
+            <a:off x="1005840" y="2697480"/>
+            <a:ext cx="2880360" cy="411480"/>
+          </a:xfrm>
+          <a:prstGeom prst="rect">
+            <a:avLst/>
+          </a:prstGeom>
+          <a:noFill/>
+          <a:ln/>
+        </p:spPr>
+        <p:txBody>
+          <a:bodyPr wrap="square" rtlCol="0" anchor="ctr"/>
+          <a:lstStyle/>
+          <a:p>
+            <a:pPr indent="0" marL="0">
+              <a:buNone/>
+            </a:pPr>
+            <a:r>
+              <a:rPr lang="en-US" sz="1000" b="1" i="1" dirty="0">
+                <a:solidFill>
+                  <a:srgbClr val="111111"/>
+                </a:solidFill>
+                <a:latin typeface="Arial" pitchFamily="34" charset="0"/>
+                <a:ea typeface="Arial" pitchFamily="34" charset="-122"/>
+                <a:cs typeface="Arial" pitchFamily="34" charset="-120"/>
+              </a:rPr>
+              <a:t>Organic Valley Cradle &amp; Acclimatization Oasis</a:t>
+            </a:r>
             <a:endParaRPr lang="en-US" sz="1000" dirty="0"/>
           </a:p>
         </p:txBody>
       </p:sp>
       <p:sp>
         <p:nvSpPr>
-          <p:cNvPr id="7" name="Text 5"/>
-          <p:cNvSpPr/>
-          <p:nvPr/>
-        </p:nvSpPr>
-        <p:spPr>
-          <a:xfrm>
-            <a:off x="1005840" y="2926080"/>
-            <a:ext cx="2880360" cy="2743200"/>
+          <p:cNvPr id="10" name="Text 8"/>
+          <p:cNvSpPr/>
+          <p:nvPr/>
+        </p:nvSpPr>
+        <p:spPr>
+          <a:xfrm>
+            <a:off x="1005840" y="3154680"/>
+            <a:ext cx="2880360" cy="2240280"/>
           </a:xfrm>
           <a:prstGeom prst="rect">
             <a:avLst/>
@@ -6072,12 +6189,12 @@
           <a:p>
             <a:pPr indent="0" marL="0">
               <a:lnSpc>
-                <a:spcPts val="1800"/>
+                <a:spcPts val="1600"/>
               </a:lnSpc>
               <a:buNone/>
             </a:pPr>
             <a:r>
-              <a:rPr lang="en-US" sz="1150" dirty="0">
+              <a:rPr lang="en-US" sz="1050" dirty="0">
                 <a:solidFill>
                   <a:srgbClr val="444444"/>
                 </a:solidFill>
@@ -6085,22 +6202,82 @@
                 <a:ea typeface="Arial" pitchFamily="34" charset="-122"/>
                 <a:cs typeface="Arial" pitchFamily="34" charset="-120"/>
               </a:rPr>
-              <a:t>Traditional Andean hacienda set amidst fruit orchards and gardens. The ideal base to gently acclimatize at low elevation, enjoying organic garden-to-table cuisine.</a:t>
-            </a:r>
-            <a:endParaRPr lang="en-US" sz="1150" dirty="0"/>
-          </a:p>
-        </p:txBody>
-      </p:sp>
-      <p:sp>
-        <p:nvSpPr>
-          <p:cNvPr id="8" name="Shape 6"/>
-          <p:cNvSpPr/>
-          <p:nvPr/>
-        </p:nvSpPr>
-        <p:spPr>
-          <a:xfrm>
-            <a:off x="4343400" y="1645920"/>
-            <a:ext cx="3429000" cy="4389120"/>
+              <a:t>• Historic Andean country estate set amidst fruit orchards and gardens.</a:t>
+            </a:r>
+            <a:endParaRPr lang="en-US" sz="1050" dirty="0"/>
+          </a:p>
+          <a:p>
+            <a:pPr indent="0" marL="0">
+              <a:lnSpc>
+                <a:spcPts val="1600"/>
+              </a:lnSpc>
+              <a:buNone/>
+            </a:pPr>
+            <a:r>
+              <a:rPr lang="en-US" sz="1050" dirty="0">
+                <a:solidFill>
+                  <a:srgbClr val="444444"/>
+                </a:solidFill>
+                <a:latin typeface="Arial" pitchFamily="34" charset="0"/>
+                <a:ea typeface="Arial" pitchFamily="34" charset="-122"/>
+                <a:cs typeface="Arial" pitchFamily="34" charset="-120"/>
+              </a:rPr>
+              <a:t>• Sheltered valley microclimate for low-altitude oxygenation and deep sleep.</a:t>
+            </a:r>
+            <a:endParaRPr lang="en-US" sz="1050" dirty="0"/>
+          </a:p>
+          <a:p>
+            <a:pPr indent="0" marL="0">
+              <a:lnSpc>
+                <a:spcPts val="1600"/>
+              </a:lnSpc>
+              <a:buNone/>
+            </a:pPr>
+            <a:r>
+              <a:rPr lang="en-US" sz="1050" dirty="0">
+                <a:solidFill>
+                  <a:srgbClr val="444444"/>
+                </a:solidFill>
+                <a:latin typeface="Arial" pitchFamily="34" charset="0"/>
+                <a:ea typeface="Arial" pitchFamily="34" charset="-122"/>
+                <a:cs typeface="Arial" pitchFamily="34" charset="-120"/>
+              </a:rPr>
+              <a:t>• Organic farm-to-table cuisine picked fresh from the lodge huerta.</a:t>
+            </a:r>
+            <a:endParaRPr lang="en-US" sz="1050" dirty="0"/>
+          </a:p>
+          <a:p>
+            <a:pPr indent="0" marL="0">
+              <a:lnSpc>
+                <a:spcPts val="1600"/>
+              </a:lnSpc>
+              <a:buNone/>
+            </a:pPr>
+            <a:r>
+              <a:rPr lang="en-US" sz="1050" dirty="0">
+                <a:solidFill>
+                  <a:srgbClr val="444444"/>
+                </a:solidFill>
+                <a:latin typeface="Arial" pitchFamily="34" charset="0"/>
+                <a:ea typeface="Arial" pitchFamily="34" charset="-122"/>
+                <a:cs typeface="Arial" pitchFamily="34" charset="-120"/>
+              </a:rPr>
+              <a:t>• Warm fireside storytelling honoring the mountain Apus.</a:t>
+            </a:r>
+            <a:endParaRPr lang="en-US" sz="1050" dirty="0"/>
+          </a:p>
+        </p:txBody>
+      </p:sp>
+      <p:sp>
+        <p:nvSpPr>
+          <p:cNvPr id="11" name="Shape 9"/>
+          <p:cNvSpPr/>
+          <p:nvPr/>
+        </p:nvSpPr>
+        <p:spPr>
+          <a:xfrm>
+            <a:off x="4343400" y="1508760"/>
+            <a:ext cx="3429000" cy="4023360"/>
           </a:xfrm>
           <a:prstGeom prst="rect">
             <a:avLst/>
@@ -6118,30 +6295,69 @@
       </p:sp>
       <p:sp>
         <p:nvSpPr>
-          <p:cNvPr id="9" name="Text 7"/>
-          <p:cNvSpPr/>
-          <p:nvPr/>
-        </p:nvSpPr>
-        <p:spPr>
-          <a:xfrm>
-            <a:off x="4617720" y="2011680"/>
-            <a:ext cx="2880360" cy="457200"/>
-          </a:xfrm>
-          <a:prstGeom prst="rect">
-            <a:avLst/>
-          </a:prstGeom>
-          <a:noFill/>
-          <a:ln/>
-        </p:spPr>
-        <p:txBody>
-          <a:bodyPr wrap="square" rtlCol="0" anchor="ctr"/>
-          <a:lstStyle/>
-          <a:p>
-            <a:pPr indent="0" marL="0">
-              <a:buNone/>
-            </a:pPr>
-            <a:r>
-              <a:rPr lang="en-US" sz="1600" b="1" dirty="0">
+          <p:cNvPr id="12" name="Text 10"/>
+          <p:cNvSpPr/>
+          <p:nvPr/>
+        </p:nvSpPr>
+        <p:spPr>
+          <a:xfrm>
+            <a:off x="4617720" y="1691640"/>
+            <a:ext cx="2880360" cy="228600"/>
+          </a:xfrm>
+          <a:prstGeom prst="rect">
+            <a:avLst/>
+          </a:prstGeom>
+          <a:noFill/>
+          <a:ln/>
+        </p:spPr>
+        <p:txBody>
+          <a:bodyPr wrap="square" rtlCol="0" anchor="ctr"/>
+          <a:lstStyle/>
+          <a:p>
+            <a:pPr indent="0" marL="0">
+              <a:buNone/>
+            </a:pPr>
+            <a:r>
+              <a:rPr lang="en-US" sz="900" b="1" spc="200" kern="0" dirty="0">
+                <a:solidFill>
+                  <a:srgbClr val="C69255"/>
+                </a:solidFill>
+                <a:latin typeface="Arial" pitchFamily="34" charset="0"/>
+                <a:ea typeface="Arial" pitchFamily="34" charset="-122"/>
+                <a:cs typeface="Arial" pitchFamily="34" charset="-120"/>
+              </a:rPr>
+              <a:t>NIGHTS 3 &amp; 4</a:t>
+            </a:r>
+            <a:endParaRPr lang="en-US" sz="900" dirty="0"/>
+          </a:p>
+        </p:txBody>
+      </p:sp>
+      <p:sp>
+        <p:nvSpPr>
+          <p:cNvPr id="13" name="Text 11"/>
+          <p:cNvSpPr/>
+          <p:nvPr/>
+        </p:nvSpPr>
+        <p:spPr>
+          <a:xfrm>
+            <a:off x="4617720" y="1965960"/>
+            <a:ext cx="2880360" cy="411480"/>
+          </a:xfrm>
+          <a:prstGeom prst="rect">
+            <a:avLst/>
+          </a:prstGeom>
+          <a:noFill/>
+          <a:ln/>
+        </p:spPr>
+        <p:txBody>
+          <a:bodyPr wrap="square" rtlCol="0" anchor="ctr"/>
+          <a:lstStyle/>
+          <a:p>
+            <a:pPr indent="0" marL="0">
+              <a:buNone/>
+            </a:pPr>
+            <a:r>
+              <a:rPr lang="en-US" sz="1500" b="1" dirty="0">
                 <a:solidFill>
                   <a:srgbClr val="111111"/>
                 </a:solidFill>
@@ -6151,38 +6367,38 @@
               </a:rPr>
               <a:t>Wayarumi Eco-Lodge</a:t>
             </a:r>
-            <a:endParaRPr lang="en-US" sz="1600" dirty="0"/>
-          </a:p>
-        </p:txBody>
-      </p:sp>
-      <p:sp>
-        <p:nvSpPr>
-          <p:cNvPr id="10" name="Text 8"/>
-          <p:cNvSpPr/>
-          <p:nvPr/>
-        </p:nvSpPr>
-        <p:spPr>
-          <a:xfrm>
-            <a:off x="4617720" y="2468880"/>
-            <a:ext cx="2880360" cy="274320"/>
-          </a:xfrm>
-          <a:prstGeom prst="rect">
-            <a:avLst/>
-          </a:prstGeom>
-          <a:noFill/>
-          <a:ln/>
-        </p:spPr>
-        <p:txBody>
-          <a:bodyPr wrap="square" rtlCol="0" anchor="ctr"/>
-          <a:lstStyle/>
-          <a:p>
-            <a:pPr indent="0" marL="0">
-              <a:buNone/>
-            </a:pPr>
-            <a:r>
-              <a:rPr lang="en-US" sz="1000" b="1" dirty="0">
-                <a:solidFill>
-                  <a:srgbClr val="C69255"/>
+            <a:endParaRPr lang="en-US" sz="1500" dirty="0"/>
+          </a:p>
+        </p:txBody>
+      </p:sp>
+      <p:sp>
+        <p:nvSpPr>
+          <p:cNvPr id="14" name="Text 12"/>
+          <p:cNvSpPr/>
+          <p:nvPr/>
+        </p:nvSpPr>
+        <p:spPr>
+          <a:xfrm>
+            <a:off x="4617720" y="2423160"/>
+            <a:ext cx="2880360" cy="228600"/>
+          </a:xfrm>
+          <a:prstGeom prst="rect">
+            <a:avLst/>
+          </a:prstGeom>
+          <a:noFill/>
+          <a:ln/>
+        </p:spPr>
+        <p:txBody>
+          <a:bodyPr wrap="square" rtlCol="0" anchor="ctr"/>
+          <a:lstStyle/>
+          <a:p>
+            <a:pPr indent="0" marL="0">
+              <a:buNone/>
+            </a:pPr>
+            <a:r>
+              <a:rPr lang="en-US" sz="950" b="1" dirty="0">
+                <a:solidFill>
+                  <a:srgbClr val="666666"/>
                 </a:solidFill>
                 <a:latin typeface="Arial" pitchFamily="34" charset="0"/>
                 <a:ea typeface="Arial" pitchFamily="34" charset="-122"/>
@@ -6190,20 +6406,59 @@
               </a:rPr>
               <a:t>Yungay / Mancos • 8,200 ft / 2,500 m</a:t>
             </a:r>
+            <a:endParaRPr lang="en-US" sz="950" dirty="0"/>
+          </a:p>
+        </p:txBody>
+      </p:sp>
+      <p:sp>
+        <p:nvSpPr>
+          <p:cNvPr id="15" name="Text 13"/>
+          <p:cNvSpPr/>
+          <p:nvPr/>
+        </p:nvSpPr>
+        <p:spPr>
+          <a:xfrm>
+            <a:off x="4617720" y="2697480"/>
+            <a:ext cx="2880360" cy="411480"/>
+          </a:xfrm>
+          <a:prstGeom prst="rect">
+            <a:avLst/>
+          </a:prstGeom>
+          <a:noFill/>
+          <a:ln/>
+        </p:spPr>
+        <p:txBody>
+          <a:bodyPr wrap="square" rtlCol="0" anchor="ctr"/>
+          <a:lstStyle/>
+          <a:p>
+            <a:pPr indent="0" marL="0">
+              <a:buNone/>
+            </a:pPr>
+            <a:r>
+              <a:rPr lang="en-US" sz="1000" b="1" i="1" dirty="0">
+                <a:solidFill>
+                  <a:srgbClr val="111111"/>
+                </a:solidFill>
+                <a:latin typeface="Arial" pitchFamily="34" charset="0"/>
+                <a:ea typeface="Arial" pitchFamily="34" charset="-122"/>
+                <a:cs typeface="Arial" pitchFamily="34" charset="-120"/>
+              </a:rPr>
+              <a:t>Front-Row Glacier Sanctuary at Huascarán</a:t>
+            </a:r>
             <a:endParaRPr lang="en-US" sz="1000" dirty="0"/>
           </a:p>
         </p:txBody>
       </p:sp>
       <p:sp>
         <p:nvSpPr>
-          <p:cNvPr id="11" name="Text 9"/>
-          <p:cNvSpPr/>
-          <p:nvPr/>
-        </p:nvSpPr>
-        <p:spPr>
-          <a:xfrm>
-            <a:off x="4617720" y="2926080"/>
-            <a:ext cx="2880360" cy="2743200"/>
+          <p:cNvPr id="16" name="Text 14"/>
+          <p:cNvSpPr/>
+          <p:nvPr/>
+        </p:nvSpPr>
+        <p:spPr>
+          <a:xfrm>
+            <a:off x="4617720" y="3154680"/>
+            <a:ext cx="2880360" cy="2240280"/>
           </a:xfrm>
           <a:prstGeom prst="rect">
             <a:avLst/>
@@ -6217,12 +6472,12 @@
           <a:p>
             <a:pPr indent="0" marL="0">
               <a:lnSpc>
-                <a:spcPts val="1800"/>
+                <a:spcPts val="1600"/>
               </a:lnSpc>
               <a:buNone/>
             </a:pPr>
             <a:r>
-              <a:rPr lang="en-US" sz="1150" dirty="0">
+              <a:rPr lang="en-US" sz="1050" dirty="0">
                 <a:solidFill>
                   <a:srgbClr val="444444"/>
                 </a:solidFill>
@@ -6230,22 +6485,82 @@
                 <a:ea typeface="Arial" pitchFamily="34" charset="-122"/>
                 <a:cs typeface="Arial" pitchFamily="34" charset="-120"/>
               </a:rPr>
-              <a:t>Strategically positioned facing the colossal western face of Mount Huascarán. Adobe and native wood architecture, wood-burning fireplaces, and direct glacier views.</a:t>
-            </a:r>
-            <a:endParaRPr lang="en-US" sz="1150" dirty="0"/>
-          </a:p>
-        </p:txBody>
-      </p:sp>
-      <p:sp>
-        <p:nvSpPr>
-          <p:cNvPr id="12" name="Shape 10"/>
-          <p:cNvSpPr/>
-          <p:nvPr/>
-        </p:nvSpPr>
-        <p:spPr>
-          <a:xfrm>
-            <a:off x="7955280" y="1645920"/>
-            <a:ext cx="3429000" cy="4389120"/>
+              <a:t>• Positioned directly opposite the colossal western face of Mount Huascarán.</a:t>
+            </a:r>
+            <a:endParaRPr lang="en-US" sz="1050" dirty="0"/>
+          </a:p>
+          <a:p>
+            <a:pPr indent="0" marL="0">
+              <a:lnSpc>
+                <a:spcPts val="1600"/>
+              </a:lnSpc>
+              <a:buNone/>
+            </a:pPr>
+            <a:r>
+              <a:rPr lang="en-US" sz="1050" dirty="0">
+                <a:solidFill>
+                  <a:srgbClr val="444444"/>
+                </a:solidFill>
+                <a:latin typeface="Arial" pitchFamily="34" charset="0"/>
+                <a:ea typeface="Arial" pitchFamily="34" charset="-122"/>
+                <a:cs typeface="Arial" pitchFamily="34" charset="-120"/>
+              </a:rPr>
+              <a:t>• Vernacular architecture in river stone, sun-dried adobe, and native beams.</a:t>
+            </a:r>
+            <a:endParaRPr lang="en-US" sz="1050" dirty="0"/>
+          </a:p>
+          <a:p>
+            <a:pPr indent="0" marL="0">
+              <a:lnSpc>
+                <a:spcPts val="1600"/>
+              </a:lnSpc>
+              <a:buNone/>
+            </a:pPr>
+            <a:r>
+              <a:rPr lang="en-US" sz="1050" dirty="0">
+                <a:solidFill>
+                  <a:srgbClr val="444444"/>
+                </a:solidFill>
+                <a:latin typeface="Arial" pitchFamily="34" charset="0"/>
+                <a:ea typeface="Arial" pitchFamily="34" charset="-122"/>
+                <a:cs typeface="Arial" pitchFamily="34" charset="-120"/>
+              </a:rPr>
+              <a:t>• Strategic mountain outpost minimizing travel to Parón and Laguna 513.</a:t>
+            </a:r>
+            <a:endParaRPr lang="en-US" sz="1050" dirty="0"/>
+          </a:p>
+          <a:p>
+            <a:pPr indent="0" marL="0">
+              <a:lnSpc>
+                <a:spcPts val="1600"/>
+              </a:lnSpc>
+              <a:buNone/>
+            </a:pPr>
+            <a:r>
+              <a:rPr lang="en-US" sz="1050" dirty="0">
+                <a:solidFill>
+                  <a:srgbClr val="444444"/>
+                </a:solidFill>
+                <a:latin typeface="Arial" pitchFamily="34" charset="0"/>
+                <a:ea typeface="Arial" pitchFamily="34" charset="-122"/>
+                <a:cs typeface="Arial" pitchFamily="34" charset="-120"/>
+              </a:rPr>
+              <a:t>• Unpolluted dark-sky stargazing and Andean astronomy around the hearth.</a:t>
+            </a:r>
+            <a:endParaRPr lang="en-US" sz="1050" dirty="0"/>
+          </a:p>
+        </p:txBody>
+      </p:sp>
+      <p:sp>
+        <p:nvSpPr>
+          <p:cNvPr id="17" name="Shape 15"/>
+          <p:cNvSpPr/>
+          <p:nvPr/>
+        </p:nvSpPr>
+        <p:spPr>
+          <a:xfrm>
+            <a:off x="7955280" y="1508760"/>
+            <a:ext cx="3429000" cy="4023360"/>
           </a:xfrm>
           <a:prstGeom prst="rect">
             <a:avLst/>
@@ -6263,30 +6578,69 @@
       </p:sp>
       <p:sp>
         <p:nvSpPr>
-          <p:cNvPr id="13" name="Text 11"/>
-          <p:cNvSpPr/>
-          <p:nvPr/>
-        </p:nvSpPr>
-        <p:spPr>
-          <a:xfrm>
-            <a:off x="8229600" y="2011680"/>
-            <a:ext cx="2880360" cy="457200"/>
-          </a:xfrm>
-          <a:prstGeom prst="rect">
-            <a:avLst/>
-          </a:prstGeom>
-          <a:noFill/>
-          <a:ln/>
-        </p:spPr>
-        <p:txBody>
-          <a:bodyPr wrap="square" rtlCol="0" anchor="ctr"/>
-          <a:lstStyle/>
-          <a:p>
-            <a:pPr indent="0" marL="0">
-              <a:buNone/>
-            </a:pPr>
-            <a:r>
-              <a:rPr lang="en-US" sz="1600" b="1" dirty="0">
+          <p:cNvPr id="18" name="Text 16"/>
+          <p:cNvSpPr/>
+          <p:nvPr/>
+        </p:nvSpPr>
+        <p:spPr>
+          <a:xfrm>
+            <a:off x="8229600" y="1691640"/>
+            <a:ext cx="2880360" cy="228600"/>
+          </a:xfrm>
+          <a:prstGeom prst="rect">
+            <a:avLst/>
+          </a:prstGeom>
+          <a:noFill/>
+          <a:ln/>
+        </p:spPr>
+        <p:txBody>
+          <a:bodyPr wrap="square" rtlCol="0" anchor="ctr"/>
+          <a:lstStyle/>
+          <a:p>
+            <a:pPr indent="0" marL="0">
+              <a:buNone/>
+            </a:pPr>
+            <a:r>
+              <a:rPr lang="en-US" sz="900" b="1" spc="200" kern="0" dirty="0">
+                <a:solidFill>
+                  <a:srgbClr val="C69255"/>
+                </a:solidFill>
+                <a:latin typeface="Arial" pitchFamily="34" charset="0"/>
+                <a:ea typeface="Arial" pitchFamily="34" charset="-122"/>
+                <a:cs typeface="Arial" pitchFamily="34" charset="-120"/>
+              </a:rPr>
+              <a:t>NIGHT 5</a:t>
+            </a:r>
+            <a:endParaRPr lang="en-US" sz="900" dirty="0"/>
+          </a:p>
+        </p:txBody>
+      </p:sp>
+      <p:sp>
+        <p:nvSpPr>
+          <p:cNvPr id="19" name="Text 17"/>
+          <p:cNvSpPr/>
+          <p:nvPr/>
+        </p:nvSpPr>
+        <p:spPr>
+          <a:xfrm>
+            <a:off x="8229600" y="1965960"/>
+            <a:ext cx="2880360" cy="411480"/>
+          </a:xfrm>
+          <a:prstGeom prst="rect">
+            <a:avLst/>
+          </a:prstGeom>
+          <a:noFill/>
+          <a:ln/>
+        </p:spPr>
+        <p:txBody>
+          <a:bodyPr wrap="square" rtlCol="0" anchor="ctr"/>
+          <a:lstStyle/>
+          <a:p>
+            <a:pPr indent="0" marL="0">
+              <a:buNone/>
+            </a:pPr>
+            <a:r>
+              <a:rPr lang="en-US" sz="1500" b="1" dirty="0">
                 <a:solidFill>
                   <a:srgbClr val="111111"/>
                 </a:solidFill>
@@ -6296,38 +6650,38 @@
               </a:rPr>
               <a:t>Cuesta Serena Lodge</a:t>
             </a:r>
-            <a:endParaRPr lang="en-US" sz="1600" dirty="0"/>
-          </a:p>
-        </p:txBody>
-      </p:sp>
-      <p:sp>
-        <p:nvSpPr>
-          <p:cNvPr id="14" name="Text 12"/>
-          <p:cNvSpPr/>
-          <p:nvPr/>
-        </p:nvSpPr>
-        <p:spPr>
-          <a:xfrm>
-            <a:off x="8229600" y="2468880"/>
-            <a:ext cx="2880360" cy="274320"/>
-          </a:xfrm>
-          <a:prstGeom prst="rect">
-            <a:avLst/>
-          </a:prstGeom>
-          <a:noFill/>
-          <a:ln/>
-        </p:spPr>
-        <p:txBody>
-          <a:bodyPr wrap="square" rtlCol="0" anchor="ctr"/>
-          <a:lstStyle/>
-          <a:p>
-            <a:pPr indent="0" marL="0">
-              <a:buNone/>
-            </a:pPr>
-            <a:r>
-              <a:rPr lang="en-US" sz="1000" b="1" dirty="0">
-                <a:solidFill>
-                  <a:srgbClr val="C69255"/>
+            <a:endParaRPr lang="en-US" sz="1500" dirty="0"/>
+          </a:p>
+        </p:txBody>
+      </p:sp>
+      <p:sp>
+        <p:nvSpPr>
+          <p:cNvPr id="20" name="Text 18"/>
+          <p:cNvSpPr/>
+          <p:nvPr/>
+        </p:nvSpPr>
+        <p:spPr>
+          <a:xfrm>
+            <a:off x="8229600" y="2423160"/>
+            <a:ext cx="2880360" cy="228600"/>
+          </a:xfrm>
+          <a:prstGeom prst="rect">
+            <a:avLst/>
+          </a:prstGeom>
+          <a:noFill/>
+          <a:ln/>
+        </p:spPr>
+        <p:txBody>
+          <a:bodyPr wrap="square" rtlCol="0" anchor="ctr"/>
+          <a:lstStyle/>
+          <a:p>
+            <a:pPr indent="0" marL="0">
+              <a:buNone/>
+            </a:pPr>
+            <a:r>
+              <a:rPr lang="en-US" sz="950" b="1" dirty="0">
+                <a:solidFill>
+                  <a:srgbClr val="666666"/>
                 </a:solidFill>
                 <a:latin typeface="Arial" pitchFamily="34" charset="0"/>
                 <a:ea typeface="Arial" pitchFamily="34" charset="-122"/>
@@ -6335,20 +6689,59 @@
               </a:rPr>
               <a:t>Anta / Marcará • 9,180 ft / 2,800 m</a:t>
             </a:r>
+            <a:endParaRPr lang="en-US" sz="950" dirty="0"/>
+          </a:p>
+        </p:txBody>
+      </p:sp>
+      <p:sp>
+        <p:nvSpPr>
+          <p:cNvPr id="21" name="Text 19"/>
+          <p:cNvSpPr/>
+          <p:nvPr/>
+        </p:nvSpPr>
+        <p:spPr>
+          <a:xfrm>
+            <a:off x="8229600" y="2697480"/>
+            <a:ext cx="2880360" cy="411480"/>
+          </a:xfrm>
+          <a:prstGeom prst="rect">
+            <a:avLst/>
+          </a:prstGeom>
+          <a:noFill/>
+          <a:ln/>
+        </p:spPr>
+        <p:txBody>
+          <a:bodyPr wrap="square" rtlCol="0" anchor="ctr"/>
+          <a:lstStyle/>
+          <a:p>
+            <a:pPr indent="0" marL="0">
+              <a:buNone/>
+            </a:pPr>
+            <a:r>
+              <a:rPr lang="en-US" sz="1000" b="1" i="1" dirty="0">
+                <a:solidFill>
+                  <a:srgbClr val="111111"/>
+                </a:solidFill>
+                <a:latin typeface="Arial" pitchFamily="34" charset="0"/>
+                <a:ea typeface="Arial" pitchFamily="34" charset="-122"/>
+                <a:cs typeface="Arial" pitchFamily="34" charset="-120"/>
+              </a:rPr>
+              <a:t>Boutique Luxury &amp; Celebratory Alpine Finale</a:t>
+            </a:r>
             <a:endParaRPr lang="en-US" sz="1000" dirty="0"/>
           </a:p>
         </p:txBody>
       </p:sp>
       <p:sp>
         <p:nvSpPr>
-          <p:cNvPr id="15" name="Text 13"/>
-          <p:cNvSpPr/>
-          <p:nvPr/>
-        </p:nvSpPr>
-        <p:spPr>
-          <a:xfrm>
-            <a:off x="8229600" y="2926080"/>
-            <a:ext cx="2880360" cy="2743200"/>
+          <p:cNvPr id="22" name="Text 20"/>
+          <p:cNvSpPr/>
+          <p:nvPr/>
+        </p:nvSpPr>
+        <p:spPr>
+          <a:xfrm>
+            <a:off x="8229600" y="3154680"/>
+            <a:ext cx="2880360" cy="2240280"/>
           </a:xfrm>
           <a:prstGeom prst="rect">
             <a:avLst/>
@@ -6362,12 +6755,12 @@
           <a:p>
             <a:pPr indent="0" marL="0">
               <a:lnSpc>
-                <a:spcPts val="1800"/>
+                <a:spcPts val="1600"/>
               </a:lnSpc>
               <a:buNone/>
             </a:pPr>
             <a:r>
-              <a:rPr lang="en-US" sz="1150" dirty="0">
+              <a:rPr lang="en-US" sz="1050" dirty="0">
                 <a:solidFill>
                   <a:srgbClr val="444444"/>
                 </a:solidFill>
@@ -6375,9 +6768,136 @@
                 <a:ea typeface="Arial" pitchFamily="34" charset="-122"/>
                 <a:cs typeface="Arial" pitchFamily="34" charset="-120"/>
               </a:rPr>
-              <a:t>Boutique luxury lodge with an Andean spa, heated pool, and tranquil gardens gazing upon the central massif. The refined finale of comfort and wellness.</a:t>
-            </a:r>
-            <a:endParaRPr lang="en-US" sz="1150" dirty="0"/>
+              <a:t>• Refined boutique luxury retreat on seven tranquil acres of hillside gardens.</a:t>
+            </a:r>
+            <a:endParaRPr lang="en-US" sz="1050" dirty="0"/>
+          </a:p>
+          <a:p>
+            <a:pPr indent="0" marL="0">
+              <a:lnSpc>
+                <a:spcPts val="1600"/>
+              </a:lnSpc>
+              <a:buNone/>
+            </a:pPr>
+            <a:r>
+              <a:rPr lang="en-US" sz="1050" dirty="0">
+                <a:solidFill>
+                  <a:srgbClr val="444444"/>
+                </a:solidFill>
+                <a:latin typeface="Arial" pitchFamily="34" charset="0"/>
+                <a:ea typeface="Arial" pitchFamily="34" charset="-122"/>
+                <a:cs typeface="Arial" pitchFamily="34" charset="-120"/>
+              </a:rPr>
+              <a:t>• Uninterrupted 180° amphitheater views of the entire Cordillera Blanca.</a:t>
+            </a:r>
+            <a:endParaRPr lang="en-US" sz="1050" dirty="0"/>
+          </a:p>
+          <a:p>
+            <a:pPr indent="0" marL="0">
+              <a:lnSpc>
+                <a:spcPts val="1600"/>
+              </a:lnSpc>
+              <a:buNone/>
+            </a:pPr>
+            <a:r>
+              <a:rPr lang="en-US" sz="1050" dirty="0">
+                <a:solidFill>
+                  <a:srgbClr val="444444"/>
+                </a:solidFill>
+                <a:latin typeface="Arial" pitchFamily="34" charset="0"/>
+                <a:ea typeface="Arial" pitchFamily="34" charset="-122"/>
+                <a:cs typeface="Arial" pitchFamily="34" charset="-120"/>
+              </a:rPr>
+              <a:t>• Heated outdoor swimming pool, Andean herbal spa, and fire pits.</a:t>
+            </a:r>
+            <a:endParaRPr lang="en-US" sz="1050" dirty="0"/>
+          </a:p>
+          <a:p>
+            <a:pPr indent="0" marL="0">
+              <a:lnSpc>
+                <a:spcPts val="1600"/>
+              </a:lnSpc>
+              <a:buNone/>
+            </a:pPr>
+            <a:r>
+              <a:rPr lang="en-US" sz="1050" dirty="0">
+                <a:solidFill>
+                  <a:srgbClr val="444444"/>
+                </a:solidFill>
+                <a:latin typeface="Arial" pitchFamily="34" charset="0"/>
+                <a:ea typeface="Arial" pitchFamily="34" charset="-122"/>
+                <a:cs typeface="Arial" pitchFamily="34" charset="-120"/>
+              </a:rPr>
+              <a:t>• Celebration dinner with progressive valley gastronomy and artisanal pairings.</a:t>
+            </a:r>
+            <a:endParaRPr lang="en-US" sz="1050" dirty="0"/>
+          </a:p>
+        </p:txBody>
+      </p:sp>
+      <p:sp>
+        <p:nvSpPr>
+          <p:cNvPr id="23" name="Shape 21"/>
+          <p:cNvSpPr/>
+          <p:nvPr/>
+        </p:nvSpPr>
+        <p:spPr>
+          <a:xfrm>
+            <a:off x="731520" y="5669280"/>
+            <a:ext cx="10652760" cy="640080"/>
+          </a:xfrm>
+          <a:prstGeom prst="rect">
+            <a:avLst/>
+          </a:prstGeom>
+          <a:solidFill>
+            <a:srgbClr val="EBE7DF"/>
+          </a:solidFill>
+          <a:ln w="12700">
+            <a:solidFill>
+              <a:srgbClr val="D5D0C5"/>
+            </a:solidFill>
+            <a:prstDash val="solid"/>
+          </a:ln>
+        </p:spPr>
+      </p:sp>
+      <p:sp>
+        <p:nvSpPr>
+          <p:cNvPr id="24" name="Text 22"/>
+          <p:cNvSpPr/>
+          <p:nvPr/>
+        </p:nvSpPr>
+        <p:spPr>
+          <a:xfrm>
+            <a:off x="1005840" y="5760720"/>
+            <a:ext cx="10058400" cy="457200"/>
+          </a:xfrm>
+          <a:prstGeom prst="rect">
+            <a:avLst/>
+          </a:prstGeom>
+          <a:noFill/>
+          <a:ln/>
+        </p:spPr>
+        <p:txBody>
+          <a:bodyPr wrap="square" rtlCol="0" anchor="ctr"/>
+          <a:lstStyle/>
+          <a:p>
+            <a:pPr indent="0" marL="0">
+              <a:lnSpc>
+                <a:spcPts val="1400"/>
+              </a:lnSpc>
+              <a:buNone/>
+            </a:pPr>
+            <a:r>
+              <a:rPr lang="en-US" sz="950" dirty="0">
+                <a:solidFill>
+                  <a:srgbClr val="333333"/>
+                </a:solidFill>
+                <a:latin typeface="Arial" pitchFamily="34" charset="0"/>
+                <a:ea typeface="Arial" pitchFamily="34" charset="-122"/>
+                <a:cs typeface="Arial" pitchFamily="34" charset="-120"/>
+              </a:rPr>
+              <a:t>HIGH-MOUNTAIN EXTENSION BASE CAMPS: Refugio Llaca (14,665 ft / 4,470 m) — authentic stone alpine hut beneath Llaca Glacier moraine • Hotel El Abuelo (Huaraz • 10,000 ft / 3,050 m) — historic climbers’ retreat for post-summit recovery.</a:t>
+            </a:r>
+            <a:endParaRPr lang="en-US" sz="950" dirty="0"/>
           </a:p>
         </p:txBody>
       </p:sp>
@@ -7995,7 +8515,7 @@
                 <a:ea typeface="Georgia" pitchFamily="34" charset="-122"/>
                 <a:cs typeface="Georgia" pitchFamily="34" charset="-120"/>
               </a:rPr>
-              <a:t>Mercedes-Benz Sprinter 4x4</a:t>
+              <a:t>Mercedes-Benz Sprinter 4x4 Van</a:t>
             </a:r>
             <a:endParaRPr lang="en-US" sz="1400" dirty="0"/>
           </a:p>
@@ -8034,7 +8554,7 @@
                 <a:ea typeface="Arial" pitchFamily="34" charset="-122"/>
                 <a:cs typeface="Arial" pitchFamily="34" charset="-120"/>
               </a:rPr>
-              <a:t>Overland Highway Comfort</a:t>
+              <a:t>Overland Highway &amp; Valley Transit</a:t>
             </a:r>
             <a:endParaRPr lang="en-US" sz="1000" dirty="0"/>
           </a:p>
@@ -8076,7 +8596,7 @@
                 <a:ea typeface="Arial" pitchFamily="34" charset="-122"/>
                 <a:cs typeface="Arial" pitchFamily="34" charset="-120"/>
               </a:rPr>
-              <a:t>• Reclining leather seating</a:t>
+              <a:t>• Reclining leather seating &amp; generous legroom</a:t>
             </a:r>
             <a:endParaRPr lang="en-US" sz="1050" dirty="0"/>
           </a:p>
@@ -8096,7 +8616,7 @@
                 <a:ea typeface="Arial" pitchFamily="34" charset="-122"/>
                 <a:cs typeface="Arial" pitchFamily="34" charset="-120"/>
               </a:rPr>
-              <a:t>• Thermal panoramic windows</a:t>
+              <a:t>• Thermal panoramic windows for 360° views</a:t>
             </a:r>
             <a:endParaRPr lang="en-US" sz="1050" dirty="0"/>
           </a:p>
@@ -8116,7 +8636,7 @@
                 <a:ea typeface="Arial" pitchFamily="34" charset="-122"/>
                 <a:cs typeface="Arial" pitchFamily="34" charset="-120"/>
               </a:rPr>
-              <a:t>• Heavy-duty unpaved road suspension</a:t>
+              <a:t>• Heavy-duty unpaved road 4x4 suspension</a:t>
             </a:r>
             <a:endParaRPr lang="en-US" sz="1050" dirty="0"/>
           </a:p>
@@ -8136,7 +8656,7 @@
                 <a:ea typeface="Arial" pitchFamily="34" charset="-122"/>
                 <a:cs typeface="Arial" pitchFamily="34" charset="-120"/>
               </a:rPr>
-              <a:t>• Medical-grade oxygen system onboard</a:t>
+              <a:t>• Continuous-flow medical oxygen system onboard</a:t>
             </a:r>
             <a:endParaRPr lang="en-US" sz="1050" dirty="0"/>
           </a:p>
@@ -8156,7 +8676,7 @@
                 <a:ea typeface="Arial" pitchFamily="34" charset="-122"/>
                 <a:cs typeface="Arial" pitchFamily="34" charset="-120"/>
               </a:rPr>
-              <a:t>• USB charging ports and travel amenities</a:t>
+              <a:t>• USB-C charging ports and cold refreshments</a:t>
             </a:r>
             <a:endParaRPr lang="en-US" sz="1050" dirty="0"/>
           </a:p>
@@ -8220,7 +8740,7 @@
                 <a:ea typeface="Georgia" pitchFamily="34" charset="-122"/>
                 <a:cs typeface="Georgia" pitchFamily="34" charset="-120"/>
               </a:rPr>
-              <a:t>Jeep Rubicon / Toyota Prado 4WD</a:t>
+              <a:t>Jeep / Toyota Land Cruiser 4WD</a:t>
             </a:r>
             <a:endParaRPr lang="en-US" sz="1400" dirty="0"/>
           </a:p>
@@ -8259,7 +8779,7 @@
                 <a:ea typeface="Arial" pitchFamily="34" charset="-122"/>
                 <a:cs typeface="Arial" pitchFamily="34" charset="-120"/>
               </a:rPr>
-              <a:t>Access to Remote Moraine Tracks</a:t>
+              <a:t>Dedicated Expedition 4x4 for Travelers</a:t>
             </a:r>
             <a:endParaRPr lang="en-US" sz="1000" dirty="0"/>
           </a:p>
@@ -8301,7 +8821,7 @@
                 <a:ea typeface="Arial" pitchFamily="34" charset="-122"/>
                 <a:cs typeface="Arial" pitchFamily="34" charset="-120"/>
               </a:rPr>
-              <a:t>• Low-range 4WD transfer case</a:t>
+              <a:t>• Heavy-duty dual-range 4WD transfer case</a:t>
             </a:r>
             <a:endParaRPr lang="en-US" sz="1050" dirty="0"/>
           </a:p>
@@ -8321,7 +8841,7 @@
                 <a:ea typeface="Arial" pitchFamily="34" charset="-122"/>
                 <a:cs typeface="Arial" pitchFamily="34" charset="-120"/>
               </a:rPr>
-              <a:t>• Access to roadless glacial valleys</a:t>
+              <a:t>• High clearance for steep moraine tracks &amp; tarns</a:t>
             </a:r>
             <a:endParaRPr lang="en-US" sz="1050" dirty="0"/>
           </a:p>
@@ -8341,7 +8861,7 @@
                 <a:ea typeface="Arial" pitchFamily="34" charset="-122"/>
                 <a:cs typeface="Arial" pitchFamily="34" charset="-120"/>
               </a:rPr>
-              <a:t>• Small, intimate group configurations</a:t>
+              <a:t>• Intimate 3–4 traveler seating configuration</a:t>
             </a:r>
             <a:endParaRPr lang="en-US" sz="1050" dirty="0"/>
           </a:p>
@@ -8361,7 +8881,7 @@
                 <a:ea typeface="Arial" pitchFamily="34" charset="-122"/>
                 <a:cs typeface="Arial" pitchFamily="34" charset="-120"/>
               </a:rPr>
-              <a:t>• High-end bike carrier mounts</a:t>
+              <a:t>• Heavy-duty bike mounts for gravel trailheads</a:t>
             </a:r>
             <a:endParaRPr lang="en-US" sz="1050" dirty="0"/>
           </a:p>
@@ -8381,7 +8901,7 @@
                 <a:ea typeface="Arial" pitchFamily="34" charset="-122"/>
                 <a:cs typeface="Arial" pitchFamily="34" charset="-120"/>
               </a:rPr>
-              <a:t>• Garmin InReach satellite communications</a:t>
+              <a:t>• Garmin InReach satellite tracking &amp; trauma kit</a:t>
             </a:r>
             <a:endParaRPr lang="en-US" sz="1050" dirty="0"/>
           </a:p>
@@ -8445,7 +8965,7 @@
                 <a:ea typeface="Georgia" pitchFamily="34" charset="-122"/>
                 <a:cs typeface="Georgia" pitchFamily="34" charset="-120"/>
               </a:rPr>
-              <a:t>Gravel &amp; Mountain Bike Fleet</a:t>
+              <a:t>Gravel Bikes &amp; Chase Support</a:t>
             </a:r>
             <a:endParaRPr lang="en-US" sz="1400" dirty="0"/>
           </a:p>
@@ -8484,7 +9004,7 @@
                 <a:ea typeface="Arial" pitchFamily="34" charset="-122"/>
                 <a:cs typeface="Arial" pitchFamily="34" charset="-120"/>
               </a:rPr>
-              <a:t>Active Valley Exploration</a:t>
+              <a:t>Active Human-Scale Exploration</a:t>
             </a:r>
             <a:endParaRPr lang="en-US" sz="1000" dirty="0"/>
           </a:p>
@@ -8526,7 +9046,7 @@
                 <a:ea typeface="Arial" pitchFamily="34" charset="-122"/>
                 <a:cs typeface="Arial" pitchFamily="34" charset="-120"/>
               </a:rPr>
-              <a:t>• Specialized bicycles for dirt and gravel roads</a:t>
+              <a:t>• High-performance gravel &amp; mountain bicycles</a:t>
             </a:r>
             <a:endParaRPr lang="en-US" sz="1050" dirty="0"/>
           </a:p>
@@ -8546,7 +9066,7 @@
                 <a:ea typeface="Arial" pitchFamily="34" charset="-122"/>
                 <a:cs typeface="Arial" pitchFamily="34" charset="-120"/>
               </a:rPr>
-              <a:t>• Electric pedal-assist available for altitude climbs</a:t>
+              <a:t>• Electric pedal-assist available for alpine climbs</a:t>
             </a:r>
             <a:endParaRPr lang="en-US" sz="1050" dirty="0"/>
           </a:p>
@@ -8566,7 +9086,7 @@
                 <a:ea typeface="Arial" pitchFamily="34" charset="-122"/>
                 <a:cs typeface="Arial" pitchFamily="34" charset="-120"/>
               </a:rPr>
-              <a:t>• Homologated safety helmets and gear</a:t>
+              <a:t>• Homologated safety helmets and protective gear</a:t>
             </a:r>
             <a:endParaRPr lang="en-US" sz="1050" dirty="0"/>
           </a:p>
@@ -8586,7 +9106,7 @@
                 <a:ea typeface="Arial" pitchFamily="34" charset="-122"/>
                 <a:cs typeface="Arial" pitchFamily="34" charset="-120"/>
               </a:rPr>
-              <a:t>• Permanent chase vehicle support on trail</a:t>
+              <a:t>• Permanent 4WD chase vehicle support on trail</a:t>
             </a:r>
             <a:endParaRPr lang="en-US" sz="1050" dirty="0"/>
           </a:p>
@@ -9344,7 +9864,7 @@
                 <a:ea typeface="Arial" pitchFamily="34" charset="-122"/>
                 <a:cs typeface="Arial" pitchFamily="34" charset="-120"/>
               </a:rPr>
-              <a:t>but about traversing the living corridor where glacial source, ancestral canals, and community thrive.</a:t>
+              <a:t>but about traversing a territory where glaciers, ancestral canals, communities, and highland crops are deeply bound together.</a:t>
             </a:r>
             <a:endParaRPr lang="en-US" sz="1400" dirty="0"/>
           </a:p>
@@ -9964,7 +10484,7 @@
                 <a:ea typeface="Arial" pitchFamily="34" charset="-122"/>
                 <a:cs typeface="Arial" pitchFamily="34" charset="-120"/>
               </a:rPr>
-              <a:t>• Daily exploration menu (active alpine hikes, botanical walks, gravel bike routes, cultural visits)</a:t>
+              <a:t>• Curated daily explorations (active alpine hikes, botanical walks, gravel bike routes, cultural visits)</a:t>
             </a:r>
             <a:endParaRPr lang="en-US" sz="1000" dirty="0"/>
           </a:p>
@@ -10590,7 +11110,7 @@
                 <a:ea typeface="Arial" pitchFamily="34" charset="-122"/>
                 <a:cs typeface="Arial" pitchFamily="34" charset="-120"/>
               </a:rPr>
-              <a:t>Millennia-old meltwater feeds luminous turquoise moraine tarns, gravity-fed pre-Inca aqueducts, and terraced orchards cultivating export blueberries, strawberries, cut roses, and heritage potatoes.</a:t>
+              <a:t>Millennia-old meltwater feeds luminous turquoise moraine tarns, gravity-fed pre-Inca aqueducts, and fertile valley terraces that sustain the life and heritage of Andean communities, nourishing thriving harvests of export blueberries, strawberries, cut roses, and native potatoes.</a:t>
             </a:r>
             <a:endParaRPr lang="en-US" sz="1300" dirty="0"/>
           </a:p>

</xml_diff>